<commit_message>
design idea for new steps button palette
</commit_message>
<xml_diff>
--- a/specifications/specman-layouts.pptx
+++ b/specifications/specman-layouts.pptx
@@ -5,7 +5,7 @@
     <p:sldMasterId id="2147483648" r:id="rId4"/>
   </p:sldMasterIdLst>
   <p:notesMasterIdLst>
-    <p:notesMasterId r:id="rId23"/>
+    <p:notesMasterId r:id="rId24"/>
   </p:notesMasterIdLst>
   <p:sldIdLst>
     <p:sldId id="259" r:id="rId5"/>
@@ -26,6 +26,7 @@
     <p:sldId id="278" r:id="rId20"/>
     <p:sldId id="279" r:id="rId21"/>
     <p:sldId id="260" r:id="rId22"/>
+    <p:sldId id="280" r:id="rId23"/>
   </p:sldIdLst>
   <p:sldSz cx="12192000" cy="6858000"/>
   <p:notesSz cx="6858000" cy="9144000"/>
@@ -251,7 +252,7 @@
           <a:p>
             <a:fld id="{68297BE5-535F-4A47-ACDC-4AEBF6241C77}" type="datetimeFigureOut">
               <a:rPr lang="de-DE" smtClean="0"/>
-              <a:t>01.10.2026</a:t>
+              <a:t>02.10.2026</a:t>
             </a:fld>
             <a:endParaRPr lang="de-DE"/>
           </a:p>
@@ -749,7 +750,7 @@
           <a:p>
             <a:fld id="{9D2EA739-B840-41DB-9666-B44BD9009BC9}" type="datetimeFigureOut">
               <a:rPr lang="de-DE" smtClean="0"/>
-              <a:t>01.10.2026</a:t>
+              <a:t>02.10.2026</a:t>
             </a:fld>
             <a:endParaRPr lang="de-DE"/>
           </a:p>
@@ -947,7 +948,7 @@
           <a:p>
             <a:fld id="{9D2EA739-B840-41DB-9666-B44BD9009BC9}" type="datetimeFigureOut">
               <a:rPr lang="de-DE" smtClean="0"/>
-              <a:t>01.10.2026</a:t>
+              <a:t>02.10.2026</a:t>
             </a:fld>
             <a:endParaRPr lang="de-DE"/>
           </a:p>
@@ -1155,7 +1156,7 @@
           <a:p>
             <a:fld id="{9D2EA739-B840-41DB-9666-B44BD9009BC9}" type="datetimeFigureOut">
               <a:rPr lang="de-DE" smtClean="0"/>
-              <a:t>01.10.2026</a:t>
+              <a:t>02.10.2026</a:t>
             </a:fld>
             <a:endParaRPr lang="de-DE"/>
           </a:p>
@@ -1353,7 +1354,7 @@
           <a:p>
             <a:fld id="{9D2EA739-B840-41DB-9666-B44BD9009BC9}" type="datetimeFigureOut">
               <a:rPr lang="de-DE" smtClean="0"/>
-              <a:t>01.10.2026</a:t>
+              <a:t>02.10.2026</a:t>
             </a:fld>
             <a:endParaRPr lang="de-DE"/>
           </a:p>
@@ -1628,7 +1629,7 @@
           <a:p>
             <a:fld id="{9D2EA739-B840-41DB-9666-B44BD9009BC9}" type="datetimeFigureOut">
               <a:rPr lang="de-DE" smtClean="0"/>
-              <a:t>01.10.2026</a:t>
+              <a:t>02.10.2026</a:t>
             </a:fld>
             <a:endParaRPr lang="de-DE"/>
           </a:p>
@@ -1893,7 +1894,7 @@
           <a:p>
             <a:fld id="{9D2EA739-B840-41DB-9666-B44BD9009BC9}" type="datetimeFigureOut">
               <a:rPr lang="de-DE" smtClean="0"/>
-              <a:t>01.10.2026</a:t>
+              <a:t>02.10.2026</a:t>
             </a:fld>
             <a:endParaRPr lang="de-DE"/>
           </a:p>
@@ -2305,7 +2306,7 @@
           <a:p>
             <a:fld id="{9D2EA739-B840-41DB-9666-B44BD9009BC9}" type="datetimeFigureOut">
               <a:rPr lang="de-DE" smtClean="0"/>
-              <a:t>01.10.2026</a:t>
+              <a:t>02.10.2026</a:t>
             </a:fld>
             <a:endParaRPr lang="de-DE"/>
           </a:p>
@@ -2446,7 +2447,7 @@
           <a:p>
             <a:fld id="{9D2EA739-B840-41DB-9666-B44BD9009BC9}" type="datetimeFigureOut">
               <a:rPr lang="de-DE" smtClean="0"/>
-              <a:t>01.10.2026</a:t>
+              <a:t>02.10.2026</a:t>
             </a:fld>
             <a:endParaRPr lang="de-DE"/>
           </a:p>
@@ -2559,7 +2560,7 @@
           <a:p>
             <a:fld id="{9D2EA739-B840-41DB-9666-B44BD9009BC9}" type="datetimeFigureOut">
               <a:rPr lang="de-DE" smtClean="0"/>
-              <a:t>01.10.2026</a:t>
+              <a:t>02.10.2026</a:t>
             </a:fld>
             <a:endParaRPr lang="de-DE"/>
           </a:p>
@@ -2870,7 +2871,7 @@
           <a:p>
             <a:fld id="{9D2EA739-B840-41DB-9666-B44BD9009BC9}" type="datetimeFigureOut">
               <a:rPr lang="de-DE" smtClean="0"/>
-              <a:t>01.10.2026</a:t>
+              <a:t>02.10.2026</a:t>
             </a:fld>
             <a:endParaRPr lang="de-DE"/>
           </a:p>
@@ -3158,7 +3159,7 @@
           <a:p>
             <a:fld id="{9D2EA739-B840-41DB-9666-B44BD9009BC9}" type="datetimeFigureOut">
               <a:rPr lang="de-DE" smtClean="0"/>
-              <a:t>01.10.2026</a:t>
+              <a:t>02.10.2026</a:t>
             </a:fld>
             <a:endParaRPr lang="de-DE"/>
           </a:p>
@@ -3399,7 +3400,7 @@
           <a:p>
             <a:fld id="{9D2EA739-B840-41DB-9666-B44BD9009BC9}" type="datetimeFigureOut">
               <a:rPr lang="de-DE" smtClean="0"/>
-              <a:t>01.10.2026</a:t>
+              <a:t>02.10.2026</a:t>
             </a:fld>
             <a:endParaRPr lang="de-DE"/>
           </a:p>
@@ -27872,6 +27873,2377 @@
 </p:sld>
 </file>
 
+<file path=ppt/slides/slide19.xml><?xml version="1.0" encoding="utf-8"?>
+<p:sld xmlns:a="http://schemas.openxmlformats.org/drawingml/2006/main" xmlns:r="http://schemas.openxmlformats.org/officeDocument/2006/relationships" xmlns:p="http://schemas.openxmlformats.org/presentationml/2006/main">
+  <p:cSld>
+    <p:spTree>
+      <p:nvGrpSpPr>
+        <p:cNvPr id="1" name=""/>
+        <p:cNvGrpSpPr/>
+        <p:nvPr/>
+      </p:nvGrpSpPr>
+      <p:grpSpPr>
+        <a:xfrm>
+          <a:off x="0" y="0"/>
+          <a:ext cx="0" cy="0"/>
+          <a:chOff x="0" y="0"/>
+          <a:chExt cx="0" cy="0"/>
+        </a:xfrm>
+      </p:grpSpPr>
+      <p:sp>
+        <p:nvSpPr>
+          <p:cNvPr id="40" name="Rechteck: abgerundete Ecken 39">
+            <a:extLst>
+              <a:ext uri="{FF2B5EF4-FFF2-40B4-BE49-F238E27FC236}">
+                <a16:creationId xmlns:a16="http://schemas.microsoft.com/office/drawing/2014/main" id="{6221983C-B8B6-BDFA-2303-BC9292118E8F}"/>
+              </a:ext>
+            </a:extLst>
+          </p:cNvPr>
+          <p:cNvSpPr/>
+          <p:nvPr/>
+        </p:nvSpPr>
+        <p:spPr>
+          <a:xfrm>
+            <a:off x="3597401" y="2528557"/>
+            <a:ext cx="1800000" cy="1800000"/>
+          </a:xfrm>
+          <a:prstGeom prst="roundRect">
+            <a:avLst>
+              <a:gd name="adj" fmla="val 3261"/>
+            </a:avLst>
+          </a:prstGeom>
+          <a:solidFill>
+            <a:schemeClr val="bg1"/>
+          </a:solidFill>
+          <a:ln>
+            <a:solidFill>
+              <a:schemeClr val="bg1">
+                <a:lumMod val="65000"/>
+              </a:schemeClr>
+            </a:solidFill>
+          </a:ln>
+        </p:spPr>
+        <p:style>
+          <a:lnRef idx="2">
+            <a:schemeClr val="accent1">
+              <a:shade val="15000"/>
+            </a:schemeClr>
+          </a:lnRef>
+          <a:fillRef idx="1">
+            <a:schemeClr val="accent1"/>
+          </a:fillRef>
+          <a:effectRef idx="0">
+            <a:schemeClr val="accent1"/>
+          </a:effectRef>
+          <a:fontRef idx="minor">
+            <a:schemeClr val="lt1"/>
+          </a:fontRef>
+        </p:style>
+        <p:txBody>
+          <a:bodyPr rtlCol="0" anchor="ctr"/>
+          <a:lstStyle/>
+          <a:p>
+            <a:pPr algn="ctr"/>
+            <a:endParaRPr lang="de-DE"/>
+          </a:p>
+        </p:txBody>
+      </p:sp>
+      <p:sp>
+        <p:nvSpPr>
+          <p:cNvPr id="38" name="Rechteck: abgerundete Ecken 37">
+            <a:extLst>
+              <a:ext uri="{FF2B5EF4-FFF2-40B4-BE49-F238E27FC236}">
+                <a16:creationId xmlns:a16="http://schemas.microsoft.com/office/drawing/2014/main" id="{B203EC54-5F5E-F33D-367E-5A7A6A5D8C78}"/>
+              </a:ext>
+            </a:extLst>
+          </p:cNvPr>
+          <p:cNvSpPr/>
+          <p:nvPr/>
+        </p:nvSpPr>
+        <p:spPr>
+          <a:xfrm>
+            <a:off x="3597401" y="591509"/>
+            <a:ext cx="1800000" cy="1800000"/>
+          </a:xfrm>
+          <a:prstGeom prst="roundRect">
+            <a:avLst>
+              <a:gd name="adj" fmla="val 3261"/>
+            </a:avLst>
+          </a:prstGeom>
+          <a:solidFill>
+            <a:schemeClr val="bg1"/>
+          </a:solidFill>
+          <a:ln>
+            <a:solidFill>
+              <a:schemeClr val="bg1">
+                <a:lumMod val="65000"/>
+              </a:schemeClr>
+            </a:solidFill>
+          </a:ln>
+        </p:spPr>
+        <p:style>
+          <a:lnRef idx="2">
+            <a:schemeClr val="accent1">
+              <a:shade val="15000"/>
+            </a:schemeClr>
+          </a:lnRef>
+          <a:fillRef idx="1">
+            <a:schemeClr val="accent1"/>
+          </a:fillRef>
+          <a:effectRef idx="0">
+            <a:schemeClr val="accent1"/>
+          </a:effectRef>
+          <a:fontRef idx="minor">
+            <a:schemeClr val="lt1"/>
+          </a:fontRef>
+        </p:style>
+        <p:txBody>
+          <a:bodyPr rtlCol="0" anchor="ctr"/>
+          <a:lstStyle/>
+          <a:p>
+            <a:pPr algn="ctr"/>
+            <a:endParaRPr lang="de-DE"/>
+          </a:p>
+        </p:txBody>
+      </p:sp>
+      <p:sp>
+        <p:nvSpPr>
+          <p:cNvPr id="36" name="Rechteck: abgerundete Ecken 35">
+            <a:extLst>
+              <a:ext uri="{FF2B5EF4-FFF2-40B4-BE49-F238E27FC236}">
+                <a16:creationId xmlns:a16="http://schemas.microsoft.com/office/drawing/2014/main" id="{5200B1D6-09DB-DDE0-3B04-6F3FC58B48FD}"/>
+              </a:ext>
+            </a:extLst>
+          </p:cNvPr>
+          <p:cNvSpPr/>
+          <p:nvPr/>
+        </p:nvSpPr>
+        <p:spPr>
+          <a:xfrm>
+            <a:off x="1098225" y="4465605"/>
+            <a:ext cx="1800000" cy="1800000"/>
+          </a:xfrm>
+          <a:prstGeom prst="roundRect">
+            <a:avLst>
+              <a:gd name="adj" fmla="val 2556"/>
+            </a:avLst>
+          </a:prstGeom>
+          <a:solidFill>
+            <a:schemeClr val="bg1"/>
+          </a:solidFill>
+          <a:ln>
+            <a:solidFill>
+              <a:schemeClr val="bg1">
+                <a:lumMod val="65000"/>
+              </a:schemeClr>
+            </a:solidFill>
+          </a:ln>
+        </p:spPr>
+        <p:style>
+          <a:lnRef idx="2">
+            <a:schemeClr val="accent1">
+              <a:shade val="15000"/>
+            </a:schemeClr>
+          </a:lnRef>
+          <a:fillRef idx="1">
+            <a:schemeClr val="accent1"/>
+          </a:fillRef>
+          <a:effectRef idx="0">
+            <a:schemeClr val="accent1"/>
+          </a:effectRef>
+          <a:fontRef idx="minor">
+            <a:schemeClr val="lt1"/>
+          </a:fontRef>
+        </p:style>
+        <p:txBody>
+          <a:bodyPr rtlCol="0" anchor="ctr"/>
+          <a:lstStyle/>
+          <a:p>
+            <a:pPr algn="ctr"/>
+            <a:endParaRPr lang="de-DE"/>
+          </a:p>
+        </p:txBody>
+      </p:sp>
+      <p:sp>
+        <p:nvSpPr>
+          <p:cNvPr id="34" name="Rechteck: abgerundete Ecken 33">
+            <a:extLst>
+              <a:ext uri="{FF2B5EF4-FFF2-40B4-BE49-F238E27FC236}">
+                <a16:creationId xmlns:a16="http://schemas.microsoft.com/office/drawing/2014/main" id="{5DB8D821-309C-8B53-BF71-0700A1A41C98}"/>
+              </a:ext>
+            </a:extLst>
+          </p:cNvPr>
+          <p:cNvSpPr/>
+          <p:nvPr/>
+        </p:nvSpPr>
+        <p:spPr>
+          <a:xfrm>
+            <a:off x="1098225" y="2528557"/>
+            <a:ext cx="1800000" cy="1800000"/>
+          </a:xfrm>
+          <a:prstGeom prst="roundRect">
+            <a:avLst>
+              <a:gd name="adj" fmla="val 3261"/>
+            </a:avLst>
+          </a:prstGeom>
+          <a:solidFill>
+            <a:schemeClr val="bg1"/>
+          </a:solidFill>
+          <a:ln>
+            <a:solidFill>
+              <a:schemeClr val="bg1">
+                <a:lumMod val="65000"/>
+              </a:schemeClr>
+            </a:solidFill>
+          </a:ln>
+        </p:spPr>
+        <p:style>
+          <a:lnRef idx="2">
+            <a:schemeClr val="accent1">
+              <a:shade val="15000"/>
+            </a:schemeClr>
+          </a:lnRef>
+          <a:fillRef idx="1">
+            <a:schemeClr val="accent1"/>
+          </a:fillRef>
+          <a:effectRef idx="0">
+            <a:schemeClr val="accent1"/>
+          </a:effectRef>
+          <a:fontRef idx="minor">
+            <a:schemeClr val="lt1"/>
+          </a:fontRef>
+        </p:style>
+        <p:txBody>
+          <a:bodyPr rtlCol="0" anchor="ctr"/>
+          <a:lstStyle/>
+          <a:p>
+            <a:pPr algn="ctr"/>
+            <a:endParaRPr lang="de-DE"/>
+          </a:p>
+        </p:txBody>
+      </p:sp>
+      <p:sp>
+        <p:nvSpPr>
+          <p:cNvPr id="33" name="Rechteck: abgerundete Ecken 32">
+            <a:extLst>
+              <a:ext uri="{FF2B5EF4-FFF2-40B4-BE49-F238E27FC236}">
+                <a16:creationId xmlns:a16="http://schemas.microsoft.com/office/drawing/2014/main" id="{AADB1F7D-6C6F-6D77-9F62-31D42CEC17F8}"/>
+              </a:ext>
+            </a:extLst>
+          </p:cNvPr>
+          <p:cNvSpPr/>
+          <p:nvPr/>
+        </p:nvSpPr>
+        <p:spPr>
+          <a:xfrm>
+            <a:off x="1098225" y="591509"/>
+            <a:ext cx="1800000" cy="1800000"/>
+          </a:xfrm>
+          <a:prstGeom prst="roundRect">
+            <a:avLst>
+              <a:gd name="adj" fmla="val 3261"/>
+            </a:avLst>
+          </a:prstGeom>
+          <a:solidFill>
+            <a:schemeClr val="bg1"/>
+          </a:solidFill>
+          <a:ln>
+            <a:solidFill>
+              <a:schemeClr val="bg1">
+                <a:lumMod val="65000"/>
+              </a:schemeClr>
+            </a:solidFill>
+          </a:ln>
+        </p:spPr>
+        <p:style>
+          <a:lnRef idx="2">
+            <a:schemeClr val="accent1">
+              <a:shade val="15000"/>
+            </a:schemeClr>
+          </a:lnRef>
+          <a:fillRef idx="1">
+            <a:schemeClr val="accent1"/>
+          </a:fillRef>
+          <a:effectRef idx="0">
+            <a:schemeClr val="accent1"/>
+          </a:effectRef>
+          <a:fontRef idx="minor">
+            <a:schemeClr val="lt1"/>
+          </a:fontRef>
+        </p:style>
+        <p:txBody>
+          <a:bodyPr rtlCol="0" anchor="ctr"/>
+          <a:lstStyle/>
+          <a:p>
+            <a:pPr algn="ctr"/>
+            <a:endParaRPr lang="de-DE"/>
+          </a:p>
+        </p:txBody>
+      </p:sp>
+      <p:sp>
+        <p:nvSpPr>
+          <p:cNvPr id="23" name="Rechteck 22">
+            <a:extLst>
+              <a:ext uri="{FF2B5EF4-FFF2-40B4-BE49-F238E27FC236}">
+                <a16:creationId xmlns:a16="http://schemas.microsoft.com/office/drawing/2014/main" id="{D01EDB23-997C-552F-FD7F-45D1DABA7B96}"/>
+              </a:ext>
+            </a:extLst>
+          </p:cNvPr>
+          <p:cNvSpPr/>
+          <p:nvPr/>
+        </p:nvSpPr>
+        <p:spPr>
+          <a:xfrm>
+            <a:off x="1159751" y="3358976"/>
+            <a:ext cx="789800" cy="669025"/>
+          </a:xfrm>
+          <a:prstGeom prst="rect">
+            <a:avLst/>
+          </a:prstGeom>
+          <a:solidFill>
+            <a:schemeClr val="bg1">
+              <a:lumMod val="85000"/>
+            </a:schemeClr>
+          </a:solidFill>
+          <a:ln>
+            <a:noFill/>
+          </a:ln>
+        </p:spPr>
+        <p:style>
+          <a:lnRef idx="2">
+            <a:schemeClr val="accent1">
+              <a:shade val="15000"/>
+            </a:schemeClr>
+          </a:lnRef>
+          <a:fillRef idx="1">
+            <a:schemeClr val="accent1"/>
+          </a:fillRef>
+          <a:effectRef idx="0">
+            <a:schemeClr val="accent1"/>
+          </a:effectRef>
+          <a:fontRef idx="minor">
+            <a:schemeClr val="lt1"/>
+          </a:fontRef>
+        </p:style>
+        <p:txBody>
+          <a:bodyPr rtlCol="0" anchor="ctr"/>
+          <a:lstStyle/>
+          <a:p>
+            <a:pPr algn="ctr"/>
+            <a:endParaRPr lang="de-DE"/>
+          </a:p>
+        </p:txBody>
+      </p:sp>
+      <p:sp>
+        <p:nvSpPr>
+          <p:cNvPr id="19" name="Rechteck 18">
+            <a:extLst>
+              <a:ext uri="{FF2B5EF4-FFF2-40B4-BE49-F238E27FC236}">
+                <a16:creationId xmlns:a16="http://schemas.microsoft.com/office/drawing/2014/main" id="{222D9655-671B-04C6-FBC5-18DA0CD5A586}"/>
+              </a:ext>
+            </a:extLst>
+          </p:cNvPr>
+          <p:cNvSpPr/>
+          <p:nvPr/>
+        </p:nvSpPr>
+        <p:spPr>
+          <a:xfrm>
+            <a:off x="1797401" y="1366260"/>
+            <a:ext cx="1041498" cy="724693"/>
+          </a:xfrm>
+          <a:prstGeom prst="rect">
+            <a:avLst/>
+          </a:prstGeom>
+          <a:solidFill>
+            <a:schemeClr val="bg1">
+              <a:lumMod val="85000"/>
+            </a:schemeClr>
+          </a:solidFill>
+          <a:ln>
+            <a:noFill/>
+          </a:ln>
+        </p:spPr>
+        <p:style>
+          <a:lnRef idx="2">
+            <a:schemeClr val="accent1">
+              <a:shade val="15000"/>
+            </a:schemeClr>
+          </a:lnRef>
+          <a:fillRef idx="1">
+            <a:schemeClr val="accent1"/>
+          </a:fillRef>
+          <a:effectRef idx="0">
+            <a:schemeClr val="accent1"/>
+          </a:effectRef>
+          <a:fontRef idx="minor">
+            <a:schemeClr val="lt1"/>
+          </a:fontRef>
+        </p:style>
+        <p:txBody>
+          <a:bodyPr rtlCol="0" anchor="ctr"/>
+          <a:lstStyle/>
+          <a:p>
+            <a:pPr algn="ctr"/>
+            <a:endParaRPr lang="de-DE"/>
+          </a:p>
+        </p:txBody>
+      </p:sp>
+      <p:sp>
+        <p:nvSpPr>
+          <p:cNvPr id="18" name="Raute 17">
+            <a:extLst>
+              <a:ext uri="{FF2B5EF4-FFF2-40B4-BE49-F238E27FC236}">
+                <a16:creationId xmlns:a16="http://schemas.microsoft.com/office/drawing/2014/main" id="{E20E2FA5-824E-D254-44E3-7A2873EAFD5E}"/>
+              </a:ext>
+            </a:extLst>
+          </p:cNvPr>
+          <p:cNvSpPr/>
+          <p:nvPr/>
+        </p:nvSpPr>
+        <p:spPr>
+          <a:xfrm>
+            <a:off x="1152300" y="757096"/>
+            <a:ext cx="1152000" cy="1152000"/>
+          </a:xfrm>
+          <a:prstGeom prst="diamond">
+            <a:avLst/>
+          </a:prstGeom>
+          <a:solidFill>
+            <a:schemeClr val="bg1"/>
+          </a:solidFill>
+          <a:ln w="57150">
+            <a:solidFill>
+              <a:schemeClr val="bg1"/>
+            </a:solidFill>
+          </a:ln>
+        </p:spPr>
+        <p:style>
+          <a:lnRef idx="2">
+            <a:schemeClr val="accent1">
+              <a:shade val="15000"/>
+            </a:schemeClr>
+          </a:lnRef>
+          <a:fillRef idx="1">
+            <a:schemeClr val="accent1"/>
+          </a:fillRef>
+          <a:effectRef idx="0">
+            <a:schemeClr val="accent1"/>
+          </a:effectRef>
+          <a:fontRef idx="minor">
+            <a:schemeClr val="lt1"/>
+          </a:fontRef>
+        </p:style>
+        <p:txBody>
+          <a:bodyPr rtlCol="0" anchor="ctr"/>
+          <a:lstStyle/>
+          <a:p>
+            <a:pPr algn="ctr"/>
+            <a:endParaRPr lang="de-DE"/>
+          </a:p>
+        </p:txBody>
+      </p:sp>
+      <p:sp>
+        <p:nvSpPr>
+          <p:cNvPr id="4" name="Rechteck 3">
+            <a:extLst>
+              <a:ext uri="{FF2B5EF4-FFF2-40B4-BE49-F238E27FC236}">
+                <a16:creationId xmlns:a16="http://schemas.microsoft.com/office/drawing/2014/main" id="{2CCFEC2F-D7AF-D25B-83C4-52D794C2CFA0}"/>
+              </a:ext>
+            </a:extLst>
+          </p:cNvPr>
+          <p:cNvSpPr/>
+          <p:nvPr/>
+        </p:nvSpPr>
+        <p:spPr>
+          <a:xfrm>
+            <a:off x="3873337" y="928424"/>
+            <a:ext cx="1144499" cy="1162521"/>
+          </a:xfrm>
+          <a:prstGeom prst="rect">
+            <a:avLst/>
+          </a:prstGeom>
+          <a:noFill/>
+          <a:ln w="57150">
+            <a:solidFill>
+              <a:schemeClr val="tx1"/>
+            </a:solidFill>
+          </a:ln>
+        </p:spPr>
+        <p:style>
+          <a:lnRef idx="2">
+            <a:schemeClr val="accent1">
+              <a:shade val="15000"/>
+            </a:schemeClr>
+          </a:lnRef>
+          <a:fillRef idx="1">
+            <a:schemeClr val="accent1"/>
+          </a:fillRef>
+          <a:effectRef idx="0">
+            <a:schemeClr val="accent1"/>
+          </a:effectRef>
+          <a:fontRef idx="minor">
+            <a:schemeClr val="lt1"/>
+          </a:fontRef>
+        </p:style>
+        <p:txBody>
+          <a:bodyPr rtlCol="0" anchor="ctr"/>
+          <a:lstStyle/>
+          <a:p>
+            <a:pPr algn="ctr"/>
+            <a:endParaRPr lang="de-DE"/>
+          </a:p>
+        </p:txBody>
+      </p:sp>
+      <p:sp>
+        <p:nvSpPr>
+          <p:cNvPr id="5" name="Gleichschenkliges Dreieck 4">
+            <a:extLst>
+              <a:ext uri="{FF2B5EF4-FFF2-40B4-BE49-F238E27FC236}">
+                <a16:creationId xmlns:a16="http://schemas.microsoft.com/office/drawing/2014/main" id="{9604C5C9-9AD1-88E6-EE57-A108974656A5}"/>
+              </a:ext>
+            </a:extLst>
+          </p:cNvPr>
+          <p:cNvSpPr/>
+          <p:nvPr/>
+        </p:nvSpPr>
+        <p:spPr>
+          <a:xfrm rot="16200000">
+            <a:off x="3528593" y="1085636"/>
+            <a:ext cx="1158395" cy="852217"/>
+          </a:xfrm>
+          <a:prstGeom prst="triangle">
+            <a:avLst/>
+          </a:prstGeom>
+          <a:solidFill>
+            <a:schemeClr val="bg1">
+              <a:lumMod val="85000"/>
+            </a:schemeClr>
+          </a:solidFill>
+          <a:ln w="57150">
+            <a:solidFill>
+              <a:schemeClr val="bg1"/>
+            </a:solidFill>
+          </a:ln>
+        </p:spPr>
+        <p:style>
+          <a:lnRef idx="2">
+            <a:schemeClr val="accent1">
+              <a:shade val="15000"/>
+            </a:schemeClr>
+          </a:lnRef>
+          <a:fillRef idx="1">
+            <a:schemeClr val="accent1"/>
+          </a:fillRef>
+          <a:effectRef idx="0">
+            <a:schemeClr val="accent1"/>
+          </a:effectRef>
+          <a:fontRef idx="minor">
+            <a:schemeClr val="lt1"/>
+          </a:fontRef>
+        </p:style>
+        <p:txBody>
+          <a:bodyPr rtlCol="0" anchor="ctr"/>
+          <a:lstStyle/>
+          <a:p>
+            <a:pPr algn="ctr"/>
+            <a:endParaRPr lang="de-DE"/>
+          </a:p>
+        </p:txBody>
+      </p:sp>
+      <p:sp>
+        <p:nvSpPr>
+          <p:cNvPr id="14" name="Raute 13">
+            <a:extLst>
+              <a:ext uri="{FF2B5EF4-FFF2-40B4-BE49-F238E27FC236}">
+                <a16:creationId xmlns:a16="http://schemas.microsoft.com/office/drawing/2014/main" id="{B2E591A7-93AD-0A75-5835-4DD5C055BFDA}"/>
+              </a:ext>
+            </a:extLst>
+          </p:cNvPr>
+          <p:cNvSpPr/>
+          <p:nvPr/>
+        </p:nvSpPr>
+        <p:spPr>
+          <a:xfrm>
+            <a:off x="1241200" y="841667"/>
+            <a:ext cx="972000" cy="972000"/>
+          </a:xfrm>
+          <a:prstGeom prst="diamond">
+            <a:avLst/>
+          </a:prstGeom>
+          <a:solidFill>
+            <a:schemeClr val="bg1"/>
+          </a:solidFill>
+          <a:ln w="57150">
+            <a:solidFill>
+              <a:schemeClr val="tx1"/>
+            </a:solidFill>
+          </a:ln>
+        </p:spPr>
+        <p:style>
+          <a:lnRef idx="2">
+            <a:schemeClr val="accent1">
+              <a:shade val="15000"/>
+            </a:schemeClr>
+          </a:lnRef>
+          <a:fillRef idx="1">
+            <a:schemeClr val="accent1"/>
+          </a:fillRef>
+          <a:effectRef idx="0">
+            <a:schemeClr val="accent1"/>
+          </a:effectRef>
+          <a:fontRef idx="minor">
+            <a:schemeClr val="lt1"/>
+          </a:fontRef>
+        </p:style>
+        <p:txBody>
+          <a:bodyPr rtlCol="0" anchor="ctr"/>
+          <a:lstStyle/>
+          <a:p>
+            <a:pPr algn="ctr"/>
+            <a:endParaRPr lang="de-DE"/>
+          </a:p>
+        </p:txBody>
+      </p:sp>
+      <p:sp>
+        <p:nvSpPr>
+          <p:cNvPr id="20" name="Rechteck 19">
+            <a:extLst>
+              <a:ext uri="{FF2B5EF4-FFF2-40B4-BE49-F238E27FC236}">
+                <a16:creationId xmlns:a16="http://schemas.microsoft.com/office/drawing/2014/main" id="{EC616EE5-49A6-925C-0AFF-1BAB287F35C6}"/>
+              </a:ext>
+            </a:extLst>
+          </p:cNvPr>
+          <p:cNvSpPr/>
+          <p:nvPr/>
+        </p:nvSpPr>
+        <p:spPr>
+          <a:xfrm>
+            <a:off x="2038451" y="3348117"/>
+            <a:ext cx="792000" cy="679884"/>
+          </a:xfrm>
+          <a:prstGeom prst="rect">
+            <a:avLst/>
+          </a:prstGeom>
+          <a:solidFill>
+            <a:schemeClr val="bg1">
+              <a:lumMod val="85000"/>
+            </a:schemeClr>
+          </a:solidFill>
+          <a:ln>
+            <a:noFill/>
+          </a:ln>
+        </p:spPr>
+        <p:style>
+          <a:lnRef idx="2">
+            <a:schemeClr val="accent1">
+              <a:shade val="15000"/>
+            </a:schemeClr>
+          </a:lnRef>
+          <a:fillRef idx="1">
+            <a:schemeClr val="accent1"/>
+          </a:fillRef>
+          <a:effectRef idx="0">
+            <a:schemeClr val="accent1"/>
+          </a:effectRef>
+          <a:fontRef idx="minor">
+            <a:schemeClr val="lt1"/>
+          </a:fontRef>
+        </p:style>
+        <p:txBody>
+          <a:bodyPr rtlCol="0" anchor="ctr"/>
+          <a:lstStyle/>
+          <a:p>
+            <a:pPr algn="ctr"/>
+            <a:endParaRPr lang="de-DE"/>
+          </a:p>
+        </p:txBody>
+      </p:sp>
+      <p:sp>
+        <p:nvSpPr>
+          <p:cNvPr id="21" name="Raute 20">
+            <a:extLst>
+              <a:ext uri="{FF2B5EF4-FFF2-40B4-BE49-F238E27FC236}">
+                <a16:creationId xmlns:a16="http://schemas.microsoft.com/office/drawing/2014/main" id="{8347D9D7-7B25-C171-F3E0-59B5649DBF9E}"/>
+              </a:ext>
+            </a:extLst>
+          </p:cNvPr>
+          <p:cNvSpPr/>
+          <p:nvPr/>
+        </p:nvSpPr>
+        <p:spPr>
+          <a:xfrm>
+            <a:off x="1419101" y="2738953"/>
+            <a:ext cx="1152000" cy="1152000"/>
+          </a:xfrm>
+          <a:prstGeom prst="diamond">
+            <a:avLst/>
+          </a:prstGeom>
+          <a:solidFill>
+            <a:schemeClr val="bg1"/>
+          </a:solidFill>
+          <a:ln w="57150">
+            <a:solidFill>
+              <a:schemeClr val="bg1"/>
+            </a:solidFill>
+          </a:ln>
+        </p:spPr>
+        <p:style>
+          <a:lnRef idx="2">
+            <a:schemeClr val="accent1">
+              <a:shade val="15000"/>
+            </a:schemeClr>
+          </a:lnRef>
+          <a:fillRef idx="1">
+            <a:schemeClr val="accent1"/>
+          </a:fillRef>
+          <a:effectRef idx="0">
+            <a:schemeClr val="accent1"/>
+          </a:effectRef>
+          <a:fontRef idx="minor">
+            <a:schemeClr val="lt1"/>
+          </a:fontRef>
+        </p:style>
+        <p:txBody>
+          <a:bodyPr rtlCol="0" anchor="ctr"/>
+          <a:lstStyle/>
+          <a:p>
+            <a:pPr algn="ctr"/>
+            <a:endParaRPr lang="de-DE"/>
+          </a:p>
+        </p:txBody>
+      </p:sp>
+      <p:sp>
+        <p:nvSpPr>
+          <p:cNvPr id="22" name="Raute 21">
+            <a:extLst>
+              <a:ext uri="{FF2B5EF4-FFF2-40B4-BE49-F238E27FC236}">
+                <a16:creationId xmlns:a16="http://schemas.microsoft.com/office/drawing/2014/main" id="{4A95302C-2485-4F2B-F17E-C23E3ECDF5C6}"/>
+              </a:ext>
+            </a:extLst>
+          </p:cNvPr>
+          <p:cNvSpPr/>
+          <p:nvPr/>
+        </p:nvSpPr>
+        <p:spPr>
+          <a:xfrm>
+            <a:off x="1508001" y="2823524"/>
+            <a:ext cx="972000" cy="972000"/>
+          </a:xfrm>
+          <a:prstGeom prst="diamond">
+            <a:avLst/>
+          </a:prstGeom>
+          <a:solidFill>
+            <a:schemeClr val="bg1"/>
+          </a:solidFill>
+          <a:ln w="57150">
+            <a:solidFill>
+              <a:schemeClr val="tx1"/>
+            </a:solidFill>
+          </a:ln>
+        </p:spPr>
+        <p:style>
+          <a:lnRef idx="2">
+            <a:schemeClr val="accent1">
+              <a:shade val="15000"/>
+            </a:schemeClr>
+          </a:lnRef>
+          <a:fillRef idx="1">
+            <a:schemeClr val="accent1"/>
+          </a:fillRef>
+          <a:effectRef idx="0">
+            <a:schemeClr val="accent1"/>
+          </a:effectRef>
+          <a:fontRef idx="minor">
+            <a:schemeClr val="lt1"/>
+          </a:fontRef>
+        </p:style>
+        <p:txBody>
+          <a:bodyPr rtlCol="0" anchor="ctr"/>
+          <a:lstStyle/>
+          <a:p>
+            <a:pPr algn="ctr"/>
+            <a:endParaRPr lang="de-DE"/>
+          </a:p>
+        </p:txBody>
+      </p:sp>
+      <p:sp>
+        <p:nvSpPr>
+          <p:cNvPr id="24" name="Rechteck 23">
+            <a:extLst>
+              <a:ext uri="{FF2B5EF4-FFF2-40B4-BE49-F238E27FC236}">
+                <a16:creationId xmlns:a16="http://schemas.microsoft.com/office/drawing/2014/main" id="{310F0061-092E-AC8B-1F1D-F86FD382D7E8}"/>
+              </a:ext>
+            </a:extLst>
+          </p:cNvPr>
+          <p:cNvSpPr/>
+          <p:nvPr/>
+        </p:nvSpPr>
+        <p:spPr>
+          <a:xfrm>
+            <a:off x="1159751" y="5256823"/>
+            <a:ext cx="532650" cy="759509"/>
+          </a:xfrm>
+          <a:prstGeom prst="rect">
+            <a:avLst/>
+          </a:prstGeom>
+          <a:solidFill>
+            <a:schemeClr val="bg1">
+              <a:lumMod val="85000"/>
+            </a:schemeClr>
+          </a:solidFill>
+          <a:ln>
+            <a:noFill/>
+          </a:ln>
+        </p:spPr>
+        <p:style>
+          <a:lnRef idx="2">
+            <a:schemeClr val="accent1">
+              <a:shade val="15000"/>
+            </a:schemeClr>
+          </a:lnRef>
+          <a:fillRef idx="1">
+            <a:schemeClr val="accent1"/>
+          </a:fillRef>
+          <a:effectRef idx="0">
+            <a:schemeClr val="accent1"/>
+          </a:effectRef>
+          <a:fontRef idx="minor">
+            <a:schemeClr val="lt1"/>
+          </a:fontRef>
+        </p:style>
+        <p:txBody>
+          <a:bodyPr rtlCol="0" anchor="ctr"/>
+          <a:lstStyle/>
+          <a:p>
+            <a:pPr algn="ctr"/>
+            <a:endParaRPr lang="de-DE"/>
+          </a:p>
+        </p:txBody>
+      </p:sp>
+      <p:sp>
+        <p:nvSpPr>
+          <p:cNvPr id="25" name="Rechteck 24">
+            <a:extLst>
+              <a:ext uri="{FF2B5EF4-FFF2-40B4-BE49-F238E27FC236}">
+                <a16:creationId xmlns:a16="http://schemas.microsoft.com/office/drawing/2014/main" id="{314A6C14-62BE-1D24-5ED7-31F707714FA2}"/>
+              </a:ext>
+            </a:extLst>
+          </p:cNvPr>
+          <p:cNvSpPr/>
+          <p:nvPr/>
+        </p:nvSpPr>
+        <p:spPr>
+          <a:xfrm>
+            <a:off x="1797401" y="5245964"/>
+            <a:ext cx="506899" cy="770367"/>
+          </a:xfrm>
+          <a:prstGeom prst="rect">
+            <a:avLst/>
+          </a:prstGeom>
+          <a:solidFill>
+            <a:schemeClr val="bg1">
+              <a:lumMod val="85000"/>
+            </a:schemeClr>
+          </a:solidFill>
+          <a:ln>
+            <a:noFill/>
+          </a:ln>
+        </p:spPr>
+        <p:style>
+          <a:lnRef idx="2">
+            <a:schemeClr val="accent1">
+              <a:shade val="15000"/>
+            </a:schemeClr>
+          </a:lnRef>
+          <a:fillRef idx="1">
+            <a:schemeClr val="accent1"/>
+          </a:fillRef>
+          <a:effectRef idx="0">
+            <a:schemeClr val="accent1"/>
+          </a:effectRef>
+          <a:fontRef idx="minor">
+            <a:schemeClr val="lt1"/>
+          </a:fontRef>
+        </p:style>
+        <p:txBody>
+          <a:bodyPr rtlCol="0" anchor="ctr"/>
+          <a:lstStyle/>
+          <a:p>
+            <a:pPr algn="ctr"/>
+            <a:endParaRPr lang="de-DE"/>
+          </a:p>
+        </p:txBody>
+      </p:sp>
+      <p:sp>
+        <p:nvSpPr>
+          <p:cNvPr id="26" name="Raute 25">
+            <a:extLst>
+              <a:ext uri="{FF2B5EF4-FFF2-40B4-BE49-F238E27FC236}">
+                <a16:creationId xmlns:a16="http://schemas.microsoft.com/office/drawing/2014/main" id="{C7D9180A-62D8-F701-3689-8FB5F8A0B61A}"/>
+              </a:ext>
+            </a:extLst>
+          </p:cNvPr>
+          <p:cNvSpPr/>
+          <p:nvPr/>
+        </p:nvSpPr>
+        <p:spPr>
+          <a:xfrm>
+            <a:off x="1161951" y="4636801"/>
+            <a:ext cx="1152000" cy="1152000"/>
+          </a:xfrm>
+          <a:prstGeom prst="diamond">
+            <a:avLst/>
+          </a:prstGeom>
+          <a:solidFill>
+            <a:schemeClr val="bg1"/>
+          </a:solidFill>
+          <a:ln w="57150">
+            <a:solidFill>
+              <a:schemeClr val="bg1"/>
+            </a:solidFill>
+          </a:ln>
+        </p:spPr>
+        <p:style>
+          <a:lnRef idx="2">
+            <a:schemeClr val="accent1">
+              <a:shade val="15000"/>
+            </a:schemeClr>
+          </a:lnRef>
+          <a:fillRef idx="1">
+            <a:schemeClr val="accent1"/>
+          </a:fillRef>
+          <a:effectRef idx="0">
+            <a:schemeClr val="accent1"/>
+          </a:effectRef>
+          <a:fontRef idx="minor">
+            <a:schemeClr val="lt1"/>
+          </a:fontRef>
+        </p:style>
+        <p:txBody>
+          <a:bodyPr rtlCol="0" anchor="ctr"/>
+          <a:lstStyle/>
+          <a:p>
+            <a:pPr algn="ctr"/>
+            <a:endParaRPr lang="de-DE"/>
+          </a:p>
+        </p:txBody>
+      </p:sp>
+      <p:sp>
+        <p:nvSpPr>
+          <p:cNvPr id="27" name="Raute 26">
+            <a:extLst>
+              <a:ext uri="{FF2B5EF4-FFF2-40B4-BE49-F238E27FC236}">
+                <a16:creationId xmlns:a16="http://schemas.microsoft.com/office/drawing/2014/main" id="{70B3C351-32A1-EA7B-EE2E-9F1A7B44CA02}"/>
+              </a:ext>
+            </a:extLst>
+          </p:cNvPr>
+          <p:cNvSpPr/>
+          <p:nvPr/>
+        </p:nvSpPr>
+        <p:spPr>
+          <a:xfrm>
+            <a:off x="1250851" y="4721372"/>
+            <a:ext cx="972000" cy="972000"/>
+          </a:xfrm>
+          <a:prstGeom prst="diamond">
+            <a:avLst/>
+          </a:prstGeom>
+          <a:solidFill>
+            <a:schemeClr val="bg1"/>
+          </a:solidFill>
+          <a:ln w="57150">
+            <a:solidFill>
+              <a:schemeClr val="tx1"/>
+            </a:solidFill>
+          </a:ln>
+        </p:spPr>
+        <p:style>
+          <a:lnRef idx="2">
+            <a:schemeClr val="accent1">
+              <a:shade val="15000"/>
+            </a:schemeClr>
+          </a:lnRef>
+          <a:fillRef idx="1">
+            <a:schemeClr val="accent1"/>
+          </a:fillRef>
+          <a:effectRef idx="0">
+            <a:schemeClr val="accent1"/>
+          </a:effectRef>
+          <a:fontRef idx="minor">
+            <a:schemeClr val="lt1"/>
+          </a:fontRef>
+        </p:style>
+        <p:txBody>
+          <a:bodyPr rtlCol="0" anchor="ctr"/>
+          <a:lstStyle/>
+          <a:p>
+            <a:pPr algn="ctr"/>
+            <a:endParaRPr lang="de-DE"/>
+          </a:p>
+        </p:txBody>
+      </p:sp>
+      <p:sp>
+        <p:nvSpPr>
+          <p:cNvPr id="29" name="Rechteck 28">
+            <a:extLst>
+              <a:ext uri="{FF2B5EF4-FFF2-40B4-BE49-F238E27FC236}">
+                <a16:creationId xmlns:a16="http://schemas.microsoft.com/office/drawing/2014/main" id="{B351E9D5-3503-F733-1DD7-1C308F008C0D}"/>
+              </a:ext>
+            </a:extLst>
+          </p:cNvPr>
+          <p:cNvSpPr/>
+          <p:nvPr/>
+        </p:nvSpPr>
+        <p:spPr>
+          <a:xfrm>
+            <a:off x="2377677" y="5245963"/>
+            <a:ext cx="452774" cy="770367"/>
+          </a:xfrm>
+          <a:prstGeom prst="rect">
+            <a:avLst/>
+          </a:prstGeom>
+          <a:solidFill>
+            <a:schemeClr val="bg1">
+              <a:lumMod val="85000"/>
+            </a:schemeClr>
+          </a:solidFill>
+          <a:ln>
+            <a:noFill/>
+          </a:ln>
+        </p:spPr>
+        <p:style>
+          <a:lnRef idx="2">
+            <a:schemeClr val="accent1">
+              <a:shade val="15000"/>
+            </a:schemeClr>
+          </a:lnRef>
+          <a:fillRef idx="1">
+            <a:schemeClr val="accent1"/>
+          </a:fillRef>
+          <a:effectRef idx="0">
+            <a:schemeClr val="accent1"/>
+          </a:effectRef>
+          <a:fontRef idx="minor">
+            <a:schemeClr val="lt1"/>
+          </a:fontRef>
+        </p:style>
+        <p:txBody>
+          <a:bodyPr rtlCol="0" anchor="ctr"/>
+          <a:lstStyle/>
+          <a:p>
+            <a:pPr algn="ctr"/>
+            <a:endParaRPr lang="de-DE"/>
+          </a:p>
+        </p:txBody>
+      </p:sp>
+      <p:cxnSp>
+        <p:nvCxnSpPr>
+          <p:cNvPr id="31" name="Gerader Verbinder 30">
+            <a:extLst>
+              <a:ext uri="{FF2B5EF4-FFF2-40B4-BE49-F238E27FC236}">
+                <a16:creationId xmlns:a16="http://schemas.microsoft.com/office/drawing/2014/main" id="{A7F77FDF-5878-CB6C-A7CA-06750E44E18A}"/>
+              </a:ext>
+            </a:extLst>
+          </p:cNvPr>
+          <p:cNvCxnSpPr/>
+          <p:nvPr/>
+        </p:nvCxnSpPr>
+        <p:spPr>
+          <a:xfrm flipH="1">
+            <a:off x="3950361" y="928424"/>
+            <a:ext cx="706582" cy="0"/>
+          </a:xfrm>
+          <a:prstGeom prst="line">
+            <a:avLst/>
+          </a:prstGeom>
+          <a:noFill/>
+          <a:ln w="57150">
+            <a:solidFill>
+              <a:schemeClr val="tx1"/>
+            </a:solidFill>
+          </a:ln>
+        </p:spPr>
+        <p:style>
+          <a:lnRef idx="2">
+            <a:schemeClr val="accent1">
+              <a:shade val="15000"/>
+            </a:schemeClr>
+          </a:lnRef>
+          <a:fillRef idx="1">
+            <a:schemeClr val="accent1"/>
+          </a:fillRef>
+          <a:effectRef idx="0">
+            <a:schemeClr val="accent1"/>
+          </a:effectRef>
+          <a:fontRef idx="minor">
+            <a:schemeClr val="lt1"/>
+          </a:fontRef>
+        </p:style>
+      </p:cxnSp>
+      <p:cxnSp>
+        <p:nvCxnSpPr>
+          <p:cNvPr id="32" name="Gerader Verbinder 31">
+            <a:extLst>
+              <a:ext uri="{FF2B5EF4-FFF2-40B4-BE49-F238E27FC236}">
+                <a16:creationId xmlns:a16="http://schemas.microsoft.com/office/drawing/2014/main" id="{415D9618-9A4C-C809-BA43-B38E58B6EA05}"/>
+              </a:ext>
+            </a:extLst>
+          </p:cNvPr>
+          <p:cNvCxnSpPr/>
+          <p:nvPr/>
+        </p:nvCxnSpPr>
+        <p:spPr>
+          <a:xfrm flipH="1">
+            <a:off x="4076601" y="2094080"/>
+            <a:ext cx="706582" cy="0"/>
+          </a:xfrm>
+          <a:prstGeom prst="line">
+            <a:avLst/>
+          </a:prstGeom>
+          <a:noFill/>
+          <a:ln w="57150">
+            <a:solidFill>
+              <a:schemeClr val="tx1"/>
+            </a:solidFill>
+          </a:ln>
+        </p:spPr>
+        <p:style>
+          <a:lnRef idx="2">
+            <a:schemeClr val="accent1">
+              <a:shade val="15000"/>
+            </a:schemeClr>
+          </a:lnRef>
+          <a:fillRef idx="1">
+            <a:schemeClr val="accent1"/>
+          </a:fillRef>
+          <a:effectRef idx="0">
+            <a:schemeClr val="accent1"/>
+          </a:effectRef>
+          <a:fontRef idx="minor">
+            <a:schemeClr val="lt1"/>
+          </a:fontRef>
+        </p:style>
+      </p:cxnSp>
+      <p:sp>
+        <p:nvSpPr>
+          <p:cNvPr id="42" name="Rechteck 41">
+            <a:extLst>
+              <a:ext uri="{FF2B5EF4-FFF2-40B4-BE49-F238E27FC236}">
+                <a16:creationId xmlns:a16="http://schemas.microsoft.com/office/drawing/2014/main" id="{192B1D75-8771-CEA4-B54D-F78A0C7E6104}"/>
+              </a:ext>
+            </a:extLst>
+          </p:cNvPr>
+          <p:cNvSpPr/>
+          <p:nvPr/>
+        </p:nvSpPr>
+        <p:spPr>
+          <a:xfrm>
+            <a:off x="3900866" y="2823524"/>
+            <a:ext cx="1144499" cy="1162521"/>
+          </a:xfrm>
+          <a:prstGeom prst="rect">
+            <a:avLst/>
+          </a:prstGeom>
+          <a:noFill/>
+          <a:ln w="57150">
+            <a:solidFill>
+              <a:schemeClr val="tx1"/>
+            </a:solidFill>
+          </a:ln>
+        </p:spPr>
+        <p:style>
+          <a:lnRef idx="2">
+            <a:schemeClr val="accent1">
+              <a:shade val="15000"/>
+            </a:schemeClr>
+          </a:lnRef>
+          <a:fillRef idx="1">
+            <a:schemeClr val="accent1"/>
+          </a:fillRef>
+          <a:effectRef idx="0">
+            <a:schemeClr val="accent1"/>
+          </a:effectRef>
+          <a:fontRef idx="minor">
+            <a:schemeClr val="lt1"/>
+          </a:fontRef>
+        </p:style>
+        <p:txBody>
+          <a:bodyPr rtlCol="0" anchor="ctr"/>
+          <a:lstStyle/>
+          <a:p>
+            <a:pPr algn="ctr"/>
+            <a:endParaRPr lang="de-DE"/>
+          </a:p>
+        </p:txBody>
+      </p:sp>
+      <p:sp>
+        <p:nvSpPr>
+          <p:cNvPr id="13" name="Gleichschenkliges Dreieck 12">
+            <a:extLst>
+              <a:ext uri="{FF2B5EF4-FFF2-40B4-BE49-F238E27FC236}">
+                <a16:creationId xmlns:a16="http://schemas.microsoft.com/office/drawing/2014/main" id="{8FC831E0-8A95-1808-D4F1-FA05DE023695}"/>
+              </a:ext>
+            </a:extLst>
+          </p:cNvPr>
+          <p:cNvSpPr/>
+          <p:nvPr/>
+        </p:nvSpPr>
+        <p:spPr>
+          <a:xfrm rot="5400000">
+            <a:off x="3637747" y="3004851"/>
+            <a:ext cx="1204478" cy="841825"/>
+          </a:xfrm>
+          <a:prstGeom prst="triangle">
+            <a:avLst/>
+          </a:prstGeom>
+          <a:solidFill>
+            <a:schemeClr val="bg1">
+              <a:lumMod val="85000"/>
+            </a:schemeClr>
+          </a:solidFill>
+          <a:ln w="57150">
+            <a:solidFill>
+              <a:schemeClr val="bg1"/>
+            </a:solidFill>
+          </a:ln>
+        </p:spPr>
+        <p:style>
+          <a:lnRef idx="2">
+            <a:schemeClr val="accent1">
+              <a:shade val="15000"/>
+            </a:schemeClr>
+          </a:lnRef>
+          <a:fillRef idx="1">
+            <a:schemeClr val="accent1"/>
+          </a:fillRef>
+          <a:effectRef idx="0">
+            <a:schemeClr val="accent1"/>
+          </a:effectRef>
+          <a:fontRef idx="minor">
+            <a:schemeClr val="lt1"/>
+          </a:fontRef>
+        </p:style>
+        <p:txBody>
+          <a:bodyPr rtlCol="0" anchor="ctr"/>
+          <a:lstStyle/>
+          <a:p>
+            <a:pPr algn="ctr"/>
+            <a:endParaRPr lang="de-DE"/>
+          </a:p>
+        </p:txBody>
+      </p:sp>
+      <p:sp>
+        <p:nvSpPr>
+          <p:cNvPr id="44" name="Rechteck: abgerundete Ecken 43">
+            <a:extLst>
+              <a:ext uri="{FF2B5EF4-FFF2-40B4-BE49-F238E27FC236}">
+                <a16:creationId xmlns:a16="http://schemas.microsoft.com/office/drawing/2014/main" id="{76076E8F-4B15-9471-DEFC-B53112854F82}"/>
+              </a:ext>
+            </a:extLst>
+          </p:cNvPr>
+          <p:cNvSpPr/>
+          <p:nvPr/>
+        </p:nvSpPr>
+        <p:spPr>
+          <a:xfrm>
+            <a:off x="3597401" y="4465605"/>
+            <a:ext cx="1800000" cy="1800000"/>
+          </a:xfrm>
+          <a:prstGeom prst="roundRect">
+            <a:avLst>
+              <a:gd name="adj" fmla="val 3261"/>
+            </a:avLst>
+          </a:prstGeom>
+          <a:solidFill>
+            <a:schemeClr val="bg1"/>
+          </a:solidFill>
+          <a:ln>
+            <a:solidFill>
+              <a:schemeClr val="bg1">
+                <a:lumMod val="65000"/>
+              </a:schemeClr>
+            </a:solidFill>
+          </a:ln>
+        </p:spPr>
+        <p:style>
+          <a:lnRef idx="2">
+            <a:schemeClr val="accent1">
+              <a:shade val="15000"/>
+            </a:schemeClr>
+          </a:lnRef>
+          <a:fillRef idx="1">
+            <a:schemeClr val="accent1"/>
+          </a:fillRef>
+          <a:effectRef idx="0">
+            <a:schemeClr val="accent1"/>
+          </a:effectRef>
+          <a:fontRef idx="minor">
+            <a:schemeClr val="lt1"/>
+          </a:fontRef>
+        </p:style>
+        <p:txBody>
+          <a:bodyPr rtlCol="0" anchor="ctr"/>
+          <a:lstStyle/>
+          <a:p>
+            <a:pPr algn="ctr"/>
+            <a:endParaRPr lang="de-DE"/>
+          </a:p>
+        </p:txBody>
+      </p:sp>
+      <p:sp>
+        <p:nvSpPr>
+          <p:cNvPr id="46" name="Rechteck 45">
+            <a:extLst>
+              <a:ext uri="{FF2B5EF4-FFF2-40B4-BE49-F238E27FC236}">
+                <a16:creationId xmlns:a16="http://schemas.microsoft.com/office/drawing/2014/main" id="{32C11F6E-4465-9126-6302-76815156D278}"/>
+              </a:ext>
+            </a:extLst>
+          </p:cNvPr>
+          <p:cNvSpPr/>
+          <p:nvPr/>
+        </p:nvSpPr>
+        <p:spPr>
+          <a:xfrm>
+            <a:off x="3900865" y="4699992"/>
+            <a:ext cx="1144499" cy="358624"/>
+          </a:xfrm>
+          <a:prstGeom prst="rect">
+            <a:avLst/>
+          </a:prstGeom>
+          <a:solidFill>
+            <a:schemeClr val="bg1">
+              <a:lumMod val="85000"/>
+            </a:schemeClr>
+          </a:solidFill>
+          <a:ln w="57150">
+            <a:solidFill>
+              <a:schemeClr val="bg1">
+                <a:lumMod val="85000"/>
+              </a:schemeClr>
+            </a:solidFill>
+          </a:ln>
+        </p:spPr>
+        <p:style>
+          <a:lnRef idx="2">
+            <a:schemeClr val="accent1">
+              <a:shade val="15000"/>
+            </a:schemeClr>
+          </a:lnRef>
+          <a:fillRef idx="1">
+            <a:schemeClr val="accent1"/>
+          </a:fillRef>
+          <a:effectRef idx="0">
+            <a:schemeClr val="accent1"/>
+          </a:effectRef>
+          <a:fontRef idx="minor">
+            <a:schemeClr val="lt1"/>
+          </a:fontRef>
+        </p:style>
+        <p:txBody>
+          <a:bodyPr rtlCol="0" anchor="ctr"/>
+          <a:lstStyle/>
+          <a:p>
+            <a:pPr algn="ctr"/>
+            <a:endParaRPr lang="de-DE"/>
+          </a:p>
+        </p:txBody>
+      </p:sp>
+      <p:sp>
+        <p:nvSpPr>
+          <p:cNvPr id="48" name="Rechteck 47">
+            <a:extLst>
+              <a:ext uri="{FF2B5EF4-FFF2-40B4-BE49-F238E27FC236}">
+                <a16:creationId xmlns:a16="http://schemas.microsoft.com/office/drawing/2014/main" id="{9F06C53B-F477-41FE-9076-B7CB4B4936C3}"/>
+              </a:ext>
+            </a:extLst>
+          </p:cNvPr>
+          <p:cNvSpPr/>
+          <p:nvPr/>
+        </p:nvSpPr>
+        <p:spPr>
+          <a:xfrm>
+            <a:off x="3900865" y="5195663"/>
+            <a:ext cx="1144499" cy="380009"/>
+          </a:xfrm>
+          <a:prstGeom prst="rect">
+            <a:avLst/>
+          </a:prstGeom>
+          <a:noFill/>
+          <a:ln w="57150">
+            <a:solidFill>
+              <a:schemeClr val="tx1"/>
+            </a:solidFill>
+          </a:ln>
+        </p:spPr>
+        <p:style>
+          <a:lnRef idx="2">
+            <a:schemeClr val="accent1">
+              <a:shade val="15000"/>
+            </a:schemeClr>
+          </a:lnRef>
+          <a:fillRef idx="1">
+            <a:schemeClr val="accent1"/>
+          </a:fillRef>
+          <a:effectRef idx="0">
+            <a:schemeClr val="accent1"/>
+          </a:effectRef>
+          <a:fontRef idx="minor">
+            <a:schemeClr val="lt1"/>
+          </a:fontRef>
+        </p:style>
+        <p:txBody>
+          <a:bodyPr rtlCol="0" anchor="ctr"/>
+          <a:lstStyle/>
+          <a:p>
+            <a:pPr algn="ctr"/>
+            <a:endParaRPr lang="de-DE"/>
+          </a:p>
+        </p:txBody>
+      </p:sp>
+      <p:sp>
+        <p:nvSpPr>
+          <p:cNvPr id="50" name="Rechteck 49">
+            <a:extLst>
+              <a:ext uri="{FF2B5EF4-FFF2-40B4-BE49-F238E27FC236}">
+                <a16:creationId xmlns:a16="http://schemas.microsoft.com/office/drawing/2014/main" id="{B1C672E0-6088-6E60-FC35-836FC3216CFA}"/>
+              </a:ext>
+            </a:extLst>
+          </p:cNvPr>
+          <p:cNvSpPr/>
+          <p:nvPr/>
+        </p:nvSpPr>
+        <p:spPr>
+          <a:xfrm>
+            <a:off x="3900865" y="5708086"/>
+            <a:ext cx="1144499" cy="380009"/>
+          </a:xfrm>
+          <a:prstGeom prst="rect">
+            <a:avLst/>
+          </a:prstGeom>
+          <a:noFill/>
+          <a:ln w="57150">
+            <a:solidFill>
+              <a:schemeClr val="tx1"/>
+            </a:solidFill>
+          </a:ln>
+        </p:spPr>
+        <p:style>
+          <a:lnRef idx="2">
+            <a:schemeClr val="accent1">
+              <a:shade val="15000"/>
+            </a:schemeClr>
+          </a:lnRef>
+          <a:fillRef idx="1">
+            <a:schemeClr val="accent1"/>
+          </a:fillRef>
+          <a:effectRef idx="0">
+            <a:schemeClr val="accent1"/>
+          </a:effectRef>
+          <a:fontRef idx="minor">
+            <a:schemeClr val="lt1"/>
+          </a:fontRef>
+        </p:style>
+        <p:txBody>
+          <a:bodyPr rtlCol="0" anchor="ctr"/>
+          <a:lstStyle/>
+          <a:p>
+            <a:pPr algn="ctr"/>
+            <a:endParaRPr lang="de-DE"/>
+          </a:p>
+        </p:txBody>
+      </p:sp>
+      <p:grpSp>
+        <p:nvGrpSpPr>
+          <p:cNvPr id="59" name="Gruppieren 58">
+            <a:extLst>
+              <a:ext uri="{FF2B5EF4-FFF2-40B4-BE49-F238E27FC236}">
+                <a16:creationId xmlns:a16="http://schemas.microsoft.com/office/drawing/2014/main" id="{9074E7CF-FE3B-47FD-BFC4-C785E535FAAB}"/>
+              </a:ext>
+            </a:extLst>
+          </p:cNvPr>
+          <p:cNvGrpSpPr/>
+          <p:nvPr/>
+        </p:nvGrpSpPr>
+        <p:grpSpPr>
+          <a:xfrm rot="16200000">
+            <a:off x="6096000" y="591509"/>
+            <a:ext cx="1800000" cy="1800000"/>
+            <a:chOff x="6378701" y="591509"/>
+            <a:chExt cx="1800000" cy="1800000"/>
+          </a:xfrm>
+        </p:grpSpPr>
+        <p:sp>
+          <p:nvSpPr>
+            <p:cNvPr id="52" name="Rechteck: abgerundete Ecken 51">
+              <a:extLst>
+                <a:ext uri="{FF2B5EF4-FFF2-40B4-BE49-F238E27FC236}">
+                  <a16:creationId xmlns:a16="http://schemas.microsoft.com/office/drawing/2014/main" id="{4D55E654-BF8A-DBBC-4F4C-3D4C8075C0CC}"/>
+                </a:ext>
+              </a:extLst>
+            </p:cNvPr>
+            <p:cNvSpPr/>
+            <p:nvPr/>
+          </p:nvSpPr>
+          <p:spPr>
+            <a:xfrm>
+              <a:off x="6378701" y="591509"/>
+              <a:ext cx="1800000" cy="1800000"/>
+            </a:xfrm>
+            <a:prstGeom prst="roundRect">
+              <a:avLst>
+                <a:gd name="adj" fmla="val 3261"/>
+              </a:avLst>
+            </a:prstGeom>
+            <a:solidFill>
+              <a:schemeClr val="bg1"/>
+            </a:solidFill>
+            <a:ln>
+              <a:solidFill>
+                <a:schemeClr val="bg1">
+                  <a:lumMod val="65000"/>
+                </a:schemeClr>
+              </a:solidFill>
+            </a:ln>
+          </p:spPr>
+          <p:style>
+            <a:lnRef idx="2">
+              <a:schemeClr val="accent1">
+                <a:shade val="15000"/>
+              </a:schemeClr>
+            </a:lnRef>
+            <a:fillRef idx="1">
+              <a:schemeClr val="accent1"/>
+            </a:fillRef>
+            <a:effectRef idx="0">
+              <a:schemeClr val="accent1"/>
+            </a:effectRef>
+            <a:fontRef idx="minor">
+              <a:schemeClr val="lt1"/>
+            </a:fontRef>
+          </p:style>
+          <p:txBody>
+            <a:bodyPr rtlCol="0" anchor="ctr"/>
+            <a:lstStyle/>
+            <a:p>
+              <a:pPr algn="ctr"/>
+              <a:endParaRPr lang="de-DE"/>
+            </a:p>
+          </p:txBody>
+        </p:sp>
+        <p:sp>
+          <p:nvSpPr>
+            <p:cNvPr id="54" name="Rechteck 53">
+              <a:extLst>
+                <a:ext uri="{FF2B5EF4-FFF2-40B4-BE49-F238E27FC236}">
+                  <a16:creationId xmlns:a16="http://schemas.microsoft.com/office/drawing/2014/main" id="{1664C078-3D31-7BE5-7097-96CAAC2A2AEC}"/>
+                </a:ext>
+              </a:extLst>
+            </p:cNvPr>
+            <p:cNvSpPr/>
+            <p:nvPr/>
+          </p:nvSpPr>
+          <p:spPr>
+            <a:xfrm>
+              <a:off x="6682165" y="825896"/>
+              <a:ext cx="1144499" cy="358624"/>
+            </a:xfrm>
+            <a:prstGeom prst="rect">
+              <a:avLst/>
+            </a:prstGeom>
+            <a:solidFill>
+              <a:schemeClr val="bg1">
+                <a:lumMod val="85000"/>
+              </a:schemeClr>
+            </a:solidFill>
+            <a:ln w="57150">
+              <a:solidFill>
+                <a:schemeClr val="bg1">
+                  <a:lumMod val="85000"/>
+                </a:schemeClr>
+              </a:solidFill>
+            </a:ln>
+          </p:spPr>
+          <p:style>
+            <a:lnRef idx="2">
+              <a:schemeClr val="accent1">
+                <a:shade val="15000"/>
+              </a:schemeClr>
+            </a:lnRef>
+            <a:fillRef idx="1">
+              <a:schemeClr val="accent1"/>
+            </a:fillRef>
+            <a:effectRef idx="0">
+              <a:schemeClr val="accent1"/>
+            </a:effectRef>
+            <a:fontRef idx="minor">
+              <a:schemeClr val="lt1"/>
+            </a:fontRef>
+          </p:style>
+          <p:txBody>
+            <a:bodyPr rtlCol="0" anchor="ctr"/>
+            <a:lstStyle/>
+            <a:p>
+              <a:pPr algn="ctr"/>
+              <a:endParaRPr lang="de-DE"/>
+            </a:p>
+          </p:txBody>
+        </p:sp>
+        <p:sp>
+          <p:nvSpPr>
+            <p:cNvPr id="56" name="Rechteck 55">
+              <a:extLst>
+                <a:ext uri="{FF2B5EF4-FFF2-40B4-BE49-F238E27FC236}">
+                  <a16:creationId xmlns:a16="http://schemas.microsoft.com/office/drawing/2014/main" id="{9D75DCF5-A352-4997-FA63-697C70A6733A}"/>
+                </a:ext>
+              </a:extLst>
+            </p:cNvPr>
+            <p:cNvSpPr/>
+            <p:nvPr/>
+          </p:nvSpPr>
+          <p:spPr>
+            <a:xfrm>
+              <a:off x="6682165" y="1321567"/>
+              <a:ext cx="1144499" cy="380009"/>
+            </a:xfrm>
+            <a:prstGeom prst="rect">
+              <a:avLst/>
+            </a:prstGeom>
+            <a:noFill/>
+            <a:ln w="57150">
+              <a:solidFill>
+                <a:schemeClr val="tx1"/>
+              </a:solidFill>
+            </a:ln>
+          </p:spPr>
+          <p:style>
+            <a:lnRef idx="2">
+              <a:schemeClr val="accent1">
+                <a:shade val="15000"/>
+              </a:schemeClr>
+            </a:lnRef>
+            <a:fillRef idx="1">
+              <a:schemeClr val="accent1"/>
+            </a:fillRef>
+            <a:effectRef idx="0">
+              <a:schemeClr val="accent1"/>
+            </a:effectRef>
+            <a:fontRef idx="minor">
+              <a:schemeClr val="lt1"/>
+            </a:fontRef>
+          </p:style>
+          <p:txBody>
+            <a:bodyPr rtlCol="0" anchor="ctr"/>
+            <a:lstStyle/>
+            <a:p>
+              <a:pPr algn="ctr"/>
+              <a:endParaRPr lang="de-DE"/>
+            </a:p>
+          </p:txBody>
+        </p:sp>
+        <p:sp>
+          <p:nvSpPr>
+            <p:cNvPr id="58" name="Rechteck 57">
+              <a:extLst>
+                <a:ext uri="{FF2B5EF4-FFF2-40B4-BE49-F238E27FC236}">
+                  <a16:creationId xmlns:a16="http://schemas.microsoft.com/office/drawing/2014/main" id="{676D49E3-FC43-DA81-F6FF-119BBB23103B}"/>
+                </a:ext>
+              </a:extLst>
+            </p:cNvPr>
+            <p:cNvSpPr/>
+            <p:nvPr/>
+          </p:nvSpPr>
+          <p:spPr>
+            <a:xfrm>
+              <a:off x="6682165" y="1833990"/>
+              <a:ext cx="1144499" cy="380009"/>
+            </a:xfrm>
+            <a:prstGeom prst="rect">
+              <a:avLst/>
+            </a:prstGeom>
+            <a:noFill/>
+            <a:ln w="57150">
+              <a:solidFill>
+                <a:schemeClr val="tx1"/>
+              </a:solidFill>
+            </a:ln>
+          </p:spPr>
+          <p:style>
+            <a:lnRef idx="2">
+              <a:schemeClr val="accent1">
+                <a:shade val="15000"/>
+              </a:schemeClr>
+            </a:lnRef>
+            <a:fillRef idx="1">
+              <a:schemeClr val="accent1"/>
+            </a:fillRef>
+            <a:effectRef idx="0">
+              <a:schemeClr val="accent1"/>
+            </a:effectRef>
+            <a:fontRef idx="minor">
+              <a:schemeClr val="lt1"/>
+            </a:fontRef>
+          </p:style>
+          <p:txBody>
+            <a:bodyPr rtlCol="0" anchor="ctr"/>
+            <a:lstStyle/>
+            <a:p>
+              <a:pPr algn="ctr"/>
+              <a:endParaRPr lang="de-DE"/>
+            </a:p>
+          </p:txBody>
+        </p:sp>
+      </p:grpSp>
+      <p:sp>
+        <p:nvSpPr>
+          <p:cNvPr id="61" name="Rechteck: abgerundete Ecken 60">
+            <a:extLst>
+              <a:ext uri="{FF2B5EF4-FFF2-40B4-BE49-F238E27FC236}">
+                <a16:creationId xmlns:a16="http://schemas.microsoft.com/office/drawing/2014/main" id="{7EE15438-B38D-BB7A-CC1A-A0B45C60F89D}"/>
+              </a:ext>
+            </a:extLst>
+          </p:cNvPr>
+          <p:cNvSpPr/>
+          <p:nvPr/>
+        </p:nvSpPr>
+        <p:spPr>
+          <a:xfrm>
+            <a:off x="6096001" y="2529000"/>
+            <a:ext cx="1800000" cy="1800000"/>
+          </a:xfrm>
+          <a:prstGeom prst="roundRect">
+            <a:avLst>
+              <a:gd name="adj" fmla="val 3261"/>
+            </a:avLst>
+          </a:prstGeom>
+          <a:solidFill>
+            <a:schemeClr val="bg1"/>
+          </a:solidFill>
+          <a:ln>
+            <a:solidFill>
+              <a:schemeClr val="bg1">
+                <a:lumMod val="65000"/>
+              </a:schemeClr>
+            </a:solidFill>
+          </a:ln>
+        </p:spPr>
+        <p:style>
+          <a:lnRef idx="2">
+            <a:schemeClr val="accent1">
+              <a:shade val="15000"/>
+            </a:schemeClr>
+          </a:lnRef>
+          <a:fillRef idx="1">
+            <a:schemeClr val="accent1"/>
+          </a:fillRef>
+          <a:effectRef idx="0">
+            <a:schemeClr val="accent1"/>
+          </a:effectRef>
+          <a:fontRef idx="minor">
+            <a:schemeClr val="lt1"/>
+          </a:fontRef>
+        </p:style>
+        <p:txBody>
+          <a:bodyPr rtlCol="0" anchor="ctr"/>
+          <a:lstStyle/>
+          <a:p>
+            <a:pPr algn="ctr"/>
+            <a:endParaRPr lang="de-DE"/>
+          </a:p>
+        </p:txBody>
+      </p:sp>
+      <p:sp>
+        <p:nvSpPr>
+          <p:cNvPr id="63" name="Rechteck 62">
+            <a:extLst>
+              <a:ext uri="{FF2B5EF4-FFF2-40B4-BE49-F238E27FC236}">
+                <a16:creationId xmlns:a16="http://schemas.microsoft.com/office/drawing/2014/main" id="{53E8D506-23C3-9143-AB6D-C10F3C0ACDC8}"/>
+              </a:ext>
+            </a:extLst>
+          </p:cNvPr>
+          <p:cNvSpPr/>
+          <p:nvPr/>
+        </p:nvSpPr>
+        <p:spPr>
+          <a:xfrm>
+            <a:off x="6399465" y="2763387"/>
+            <a:ext cx="1144499" cy="358624"/>
+          </a:xfrm>
+          <a:prstGeom prst="rect">
+            <a:avLst/>
+          </a:prstGeom>
+          <a:solidFill>
+            <a:schemeClr val="bg1">
+              <a:lumMod val="85000"/>
+            </a:schemeClr>
+          </a:solidFill>
+          <a:ln w="57150">
+            <a:solidFill>
+              <a:schemeClr val="bg1">
+                <a:lumMod val="85000"/>
+              </a:schemeClr>
+            </a:solidFill>
+          </a:ln>
+        </p:spPr>
+        <p:style>
+          <a:lnRef idx="2">
+            <a:schemeClr val="accent1">
+              <a:shade val="15000"/>
+            </a:schemeClr>
+          </a:lnRef>
+          <a:fillRef idx="1">
+            <a:schemeClr val="accent1"/>
+          </a:fillRef>
+          <a:effectRef idx="0">
+            <a:schemeClr val="accent1"/>
+          </a:effectRef>
+          <a:fontRef idx="minor">
+            <a:schemeClr val="lt1"/>
+          </a:fontRef>
+        </p:style>
+        <p:txBody>
+          <a:bodyPr rtlCol="0" anchor="ctr"/>
+          <a:lstStyle/>
+          <a:p>
+            <a:pPr algn="ctr"/>
+            <a:endParaRPr lang="de-DE"/>
+          </a:p>
+        </p:txBody>
+      </p:sp>
+      <p:sp>
+        <p:nvSpPr>
+          <p:cNvPr id="69" name="Rechteck 68">
+            <a:extLst>
+              <a:ext uri="{FF2B5EF4-FFF2-40B4-BE49-F238E27FC236}">
+                <a16:creationId xmlns:a16="http://schemas.microsoft.com/office/drawing/2014/main" id="{AF34AB4B-4A29-55B5-B98C-4B834D2E94FF}"/>
+              </a:ext>
+            </a:extLst>
+          </p:cNvPr>
+          <p:cNvSpPr/>
+          <p:nvPr/>
+        </p:nvSpPr>
+        <p:spPr>
+          <a:xfrm>
+            <a:off x="6406751" y="3795524"/>
+            <a:ext cx="1144499" cy="358624"/>
+          </a:xfrm>
+          <a:prstGeom prst="rect">
+            <a:avLst/>
+          </a:prstGeom>
+          <a:solidFill>
+            <a:schemeClr val="bg1">
+              <a:lumMod val="85000"/>
+            </a:schemeClr>
+          </a:solidFill>
+          <a:ln w="57150">
+            <a:solidFill>
+              <a:schemeClr val="bg1">
+                <a:lumMod val="85000"/>
+              </a:schemeClr>
+            </a:solidFill>
+          </a:ln>
+        </p:spPr>
+        <p:style>
+          <a:lnRef idx="2">
+            <a:schemeClr val="accent1">
+              <a:shade val="15000"/>
+            </a:schemeClr>
+          </a:lnRef>
+          <a:fillRef idx="1">
+            <a:schemeClr val="accent1"/>
+          </a:fillRef>
+          <a:effectRef idx="0">
+            <a:schemeClr val="accent1"/>
+          </a:effectRef>
+          <a:fontRef idx="minor">
+            <a:schemeClr val="lt1"/>
+          </a:fontRef>
+        </p:style>
+        <p:txBody>
+          <a:bodyPr rtlCol="0" anchor="ctr"/>
+          <a:lstStyle/>
+          <a:p>
+            <a:pPr algn="ctr"/>
+            <a:endParaRPr lang="de-DE"/>
+          </a:p>
+        </p:txBody>
+      </p:sp>
+      <p:sp>
+        <p:nvSpPr>
+          <p:cNvPr id="71" name="Rechteck 70">
+            <a:extLst>
+              <a:ext uri="{FF2B5EF4-FFF2-40B4-BE49-F238E27FC236}">
+                <a16:creationId xmlns:a16="http://schemas.microsoft.com/office/drawing/2014/main" id="{82BBC09F-F9AE-6F7D-ED52-8A989A64DDE5}"/>
+              </a:ext>
+            </a:extLst>
+          </p:cNvPr>
+          <p:cNvSpPr/>
+          <p:nvPr/>
+        </p:nvSpPr>
+        <p:spPr>
+          <a:xfrm>
+            <a:off x="6399465" y="3279455"/>
+            <a:ext cx="1144499" cy="358624"/>
+          </a:xfrm>
+          <a:prstGeom prst="rect">
+            <a:avLst/>
+          </a:prstGeom>
+          <a:solidFill>
+            <a:schemeClr val="bg1">
+              <a:lumMod val="85000"/>
+            </a:schemeClr>
+          </a:solidFill>
+          <a:ln w="57150">
+            <a:solidFill>
+              <a:schemeClr val="bg1">
+                <a:lumMod val="85000"/>
+              </a:schemeClr>
+            </a:solidFill>
+          </a:ln>
+        </p:spPr>
+        <p:style>
+          <a:lnRef idx="2">
+            <a:schemeClr val="accent1">
+              <a:shade val="15000"/>
+            </a:schemeClr>
+          </a:lnRef>
+          <a:fillRef idx="1">
+            <a:schemeClr val="accent1"/>
+          </a:fillRef>
+          <a:effectRef idx="0">
+            <a:schemeClr val="accent1"/>
+          </a:effectRef>
+          <a:fontRef idx="minor">
+            <a:schemeClr val="lt1"/>
+          </a:fontRef>
+        </p:style>
+        <p:txBody>
+          <a:bodyPr rtlCol="0" anchor="ctr"/>
+          <a:lstStyle/>
+          <a:p>
+            <a:pPr algn="ctr"/>
+            <a:endParaRPr lang="de-DE"/>
+          </a:p>
+        </p:txBody>
+      </p:sp>
+      <p:sp>
+        <p:nvSpPr>
+          <p:cNvPr id="73" name="Rechteck: abgerundete Ecken 72">
+            <a:extLst>
+              <a:ext uri="{FF2B5EF4-FFF2-40B4-BE49-F238E27FC236}">
+                <a16:creationId xmlns:a16="http://schemas.microsoft.com/office/drawing/2014/main" id="{B257B5BD-7E7D-BCE9-02A8-BFAF450C38BE}"/>
+              </a:ext>
+            </a:extLst>
+          </p:cNvPr>
+          <p:cNvSpPr/>
+          <p:nvPr/>
+        </p:nvSpPr>
+        <p:spPr>
+          <a:xfrm>
+            <a:off x="6096000" y="4479606"/>
+            <a:ext cx="1800000" cy="1800000"/>
+          </a:xfrm>
+          <a:prstGeom prst="roundRect">
+            <a:avLst>
+              <a:gd name="adj" fmla="val 3261"/>
+            </a:avLst>
+          </a:prstGeom>
+          <a:solidFill>
+            <a:schemeClr val="bg1"/>
+          </a:solidFill>
+          <a:ln>
+            <a:solidFill>
+              <a:schemeClr val="bg1">
+                <a:lumMod val="65000"/>
+              </a:schemeClr>
+            </a:solidFill>
+          </a:ln>
+        </p:spPr>
+        <p:style>
+          <a:lnRef idx="2">
+            <a:schemeClr val="accent1">
+              <a:shade val="15000"/>
+            </a:schemeClr>
+          </a:lnRef>
+          <a:fillRef idx="1">
+            <a:schemeClr val="accent1"/>
+          </a:fillRef>
+          <a:effectRef idx="0">
+            <a:schemeClr val="accent1"/>
+          </a:effectRef>
+          <a:fontRef idx="minor">
+            <a:schemeClr val="lt1"/>
+          </a:fontRef>
+        </p:style>
+        <p:txBody>
+          <a:bodyPr rtlCol="0" anchor="ctr"/>
+          <a:lstStyle/>
+          <a:p>
+            <a:pPr algn="ctr"/>
+            <a:endParaRPr lang="de-DE"/>
+          </a:p>
+        </p:txBody>
+      </p:sp>
+      <p:sp>
+        <p:nvSpPr>
+          <p:cNvPr id="82" name="L-Form 81">
+            <a:extLst>
+              <a:ext uri="{FF2B5EF4-FFF2-40B4-BE49-F238E27FC236}">
+                <a16:creationId xmlns:a16="http://schemas.microsoft.com/office/drawing/2014/main" id="{992819B2-6B8B-3C94-CF09-3C7FFF4758F7}"/>
+              </a:ext>
+            </a:extLst>
+          </p:cNvPr>
+          <p:cNvSpPr/>
+          <p:nvPr/>
+        </p:nvSpPr>
+        <p:spPr>
+          <a:xfrm rot="5400000">
+            <a:off x="6318599" y="4721373"/>
+            <a:ext cx="1320800" cy="1366723"/>
+          </a:xfrm>
+          <a:prstGeom prst="corner">
+            <a:avLst>
+              <a:gd name="adj1" fmla="val 32692"/>
+              <a:gd name="adj2" fmla="val 31731"/>
+            </a:avLst>
+          </a:prstGeom>
+          <a:noFill/>
+          <a:ln w="57150">
+            <a:solidFill>
+              <a:schemeClr val="tx1"/>
+            </a:solidFill>
+          </a:ln>
+        </p:spPr>
+        <p:style>
+          <a:lnRef idx="2">
+            <a:schemeClr val="accent1">
+              <a:shade val="15000"/>
+            </a:schemeClr>
+          </a:lnRef>
+          <a:fillRef idx="1">
+            <a:schemeClr val="accent1"/>
+          </a:fillRef>
+          <a:effectRef idx="0">
+            <a:schemeClr val="accent1"/>
+          </a:effectRef>
+          <a:fontRef idx="minor">
+            <a:schemeClr val="lt1"/>
+          </a:fontRef>
+        </p:style>
+        <p:txBody>
+          <a:bodyPr rtlCol="0" anchor="ctr"/>
+          <a:lstStyle/>
+          <a:p>
+            <a:pPr algn="ctr"/>
+            <a:endParaRPr lang="de-DE"/>
+          </a:p>
+        </p:txBody>
+      </p:sp>
+      <p:sp>
+        <p:nvSpPr>
+          <p:cNvPr id="85" name="Rechteck: abgerundete Ecken 84">
+            <a:extLst>
+              <a:ext uri="{FF2B5EF4-FFF2-40B4-BE49-F238E27FC236}">
+                <a16:creationId xmlns:a16="http://schemas.microsoft.com/office/drawing/2014/main" id="{107F8041-6999-04C4-80AF-E6E31BC15B27}"/>
+              </a:ext>
+            </a:extLst>
+          </p:cNvPr>
+          <p:cNvSpPr/>
+          <p:nvPr/>
+        </p:nvSpPr>
+        <p:spPr>
+          <a:xfrm>
+            <a:off x="8377699" y="591509"/>
+            <a:ext cx="1800000" cy="1800000"/>
+          </a:xfrm>
+          <a:prstGeom prst="roundRect">
+            <a:avLst>
+              <a:gd name="adj" fmla="val 3261"/>
+            </a:avLst>
+          </a:prstGeom>
+          <a:solidFill>
+            <a:schemeClr val="bg1"/>
+          </a:solidFill>
+          <a:ln>
+            <a:solidFill>
+              <a:schemeClr val="bg1">
+                <a:lumMod val="65000"/>
+              </a:schemeClr>
+            </a:solidFill>
+          </a:ln>
+        </p:spPr>
+        <p:style>
+          <a:lnRef idx="2">
+            <a:schemeClr val="accent1">
+              <a:shade val="15000"/>
+            </a:schemeClr>
+          </a:lnRef>
+          <a:fillRef idx="1">
+            <a:schemeClr val="accent1"/>
+          </a:fillRef>
+          <a:effectRef idx="0">
+            <a:schemeClr val="accent1"/>
+          </a:effectRef>
+          <a:fontRef idx="minor">
+            <a:schemeClr val="lt1"/>
+          </a:fontRef>
+        </p:style>
+        <p:txBody>
+          <a:bodyPr rtlCol="0" anchor="ctr"/>
+          <a:lstStyle/>
+          <a:p>
+            <a:pPr algn="ctr"/>
+            <a:endParaRPr lang="de-DE"/>
+          </a:p>
+        </p:txBody>
+      </p:sp>
+      <p:sp>
+        <p:nvSpPr>
+          <p:cNvPr id="87" name="L-Form 86">
+            <a:extLst>
+              <a:ext uri="{FF2B5EF4-FFF2-40B4-BE49-F238E27FC236}">
+                <a16:creationId xmlns:a16="http://schemas.microsoft.com/office/drawing/2014/main" id="{A8B45D53-EA96-4CDE-4FA2-BAB9778E55A3}"/>
+              </a:ext>
+            </a:extLst>
+          </p:cNvPr>
+          <p:cNvSpPr/>
+          <p:nvPr/>
+        </p:nvSpPr>
+        <p:spPr>
+          <a:xfrm rot="5400000" flipH="1">
+            <a:off x="8653235" y="814932"/>
+            <a:ext cx="1251964" cy="1366723"/>
+          </a:xfrm>
+          <a:prstGeom prst="corner">
+            <a:avLst>
+              <a:gd name="adj1" fmla="val 32692"/>
+              <a:gd name="adj2" fmla="val 31731"/>
+            </a:avLst>
+          </a:prstGeom>
+          <a:noFill/>
+          <a:ln w="57150">
+            <a:solidFill>
+              <a:schemeClr val="tx1"/>
+            </a:solidFill>
+          </a:ln>
+        </p:spPr>
+        <p:style>
+          <a:lnRef idx="2">
+            <a:schemeClr val="accent1">
+              <a:shade val="15000"/>
+            </a:schemeClr>
+          </a:lnRef>
+          <a:fillRef idx="1">
+            <a:schemeClr val="accent1"/>
+          </a:fillRef>
+          <a:effectRef idx="0">
+            <a:schemeClr val="accent1"/>
+          </a:effectRef>
+          <a:fontRef idx="minor">
+            <a:schemeClr val="lt1"/>
+          </a:fontRef>
+        </p:style>
+        <p:txBody>
+          <a:bodyPr rtlCol="0" anchor="ctr"/>
+          <a:lstStyle/>
+          <a:p>
+            <a:pPr algn="ctr"/>
+            <a:endParaRPr lang="de-DE"/>
+          </a:p>
+        </p:txBody>
+      </p:sp>
+      <p:sp>
+        <p:nvSpPr>
+          <p:cNvPr id="89" name="Pfeil: 180-Grad 88">
+            <a:extLst>
+              <a:ext uri="{FF2B5EF4-FFF2-40B4-BE49-F238E27FC236}">
+                <a16:creationId xmlns:a16="http://schemas.microsoft.com/office/drawing/2014/main" id="{C4BDC067-EADD-9C9C-253F-8B1A7D14BF5D}"/>
+              </a:ext>
+            </a:extLst>
+          </p:cNvPr>
+          <p:cNvSpPr/>
+          <p:nvPr/>
+        </p:nvSpPr>
+        <p:spPr>
+          <a:xfrm>
+            <a:off x="9161309" y="845609"/>
+            <a:ext cx="749300" cy="730185"/>
+          </a:xfrm>
+          <a:prstGeom prst="uturnArrow">
+            <a:avLst>
+              <a:gd name="adj1" fmla="val 25000"/>
+              <a:gd name="adj2" fmla="val 25000"/>
+              <a:gd name="adj3" fmla="val 23261"/>
+              <a:gd name="adj4" fmla="val 43750"/>
+              <a:gd name="adj5" fmla="val 100000"/>
+            </a:avLst>
+          </a:prstGeom>
+          <a:solidFill>
+            <a:schemeClr val="bg1">
+              <a:lumMod val="85000"/>
+            </a:schemeClr>
+          </a:solidFill>
+          <a:ln w="57150">
+            <a:solidFill>
+              <a:schemeClr val="bg1">
+                <a:lumMod val="85000"/>
+              </a:schemeClr>
+            </a:solidFill>
+          </a:ln>
+        </p:spPr>
+        <p:style>
+          <a:lnRef idx="2">
+            <a:schemeClr val="accent1">
+              <a:shade val="15000"/>
+            </a:schemeClr>
+          </a:lnRef>
+          <a:fillRef idx="1">
+            <a:schemeClr val="accent1"/>
+          </a:fillRef>
+          <a:effectRef idx="0">
+            <a:schemeClr val="accent1"/>
+          </a:effectRef>
+          <a:fontRef idx="minor">
+            <a:schemeClr val="lt1"/>
+          </a:fontRef>
+        </p:style>
+        <p:txBody>
+          <a:bodyPr rtlCol="0" anchor="ctr"/>
+          <a:lstStyle/>
+          <a:p>
+            <a:pPr algn="ctr"/>
+            <a:endParaRPr lang="de-DE"/>
+          </a:p>
+        </p:txBody>
+      </p:sp>
+      <p:sp>
+        <p:nvSpPr>
+          <p:cNvPr id="91" name="Pfeil: 180-Grad 90">
+            <a:extLst>
+              <a:ext uri="{FF2B5EF4-FFF2-40B4-BE49-F238E27FC236}">
+                <a16:creationId xmlns:a16="http://schemas.microsoft.com/office/drawing/2014/main" id="{84108AB2-E7ED-9D56-FCFF-4F82C248B37B}"/>
+              </a:ext>
+            </a:extLst>
+          </p:cNvPr>
+          <p:cNvSpPr/>
+          <p:nvPr/>
+        </p:nvSpPr>
+        <p:spPr>
+          <a:xfrm rot="10800000">
+            <a:off x="6888870" y="5334950"/>
+            <a:ext cx="749300" cy="730185"/>
+          </a:xfrm>
+          <a:prstGeom prst="uturnArrow">
+            <a:avLst>
+              <a:gd name="adj1" fmla="val 25000"/>
+              <a:gd name="adj2" fmla="val 25000"/>
+              <a:gd name="adj3" fmla="val 23261"/>
+              <a:gd name="adj4" fmla="val 43750"/>
+              <a:gd name="adj5" fmla="val 100000"/>
+            </a:avLst>
+          </a:prstGeom>
+          <a:solidFill>
+            <a:schemeClr val="bg1">
+              <a:lumMod val="85000"/>
+            </a:schemeClr>
+          </a:solidFill>
+          <a:ln w="57150">
+            <a:solidFill>
+              <a:schemeClr val="bg1">
+                <a:lumMod val="85000"/>
+              </a:schemeClr>
+            </a:solidFill>
+          </a:ln>
+        </p:spPr>
+        <p:style>
+          <a:lnRef idx="2">
+            <a:schemeClr val="accent1">
+              <a:shade val="15000"/>
+            </a:schemeClr>
+          </a:lnRef>
+          <a:fillRef idx="1">
+            <a:schemeClr val="accent1"/>
+          </a:fillRef>
+          <a:effectRef idx="0">
+            <a:schemeClr val="accent1"/>
+          </a:effectRef>
+          <a:fontRef idx="minor">
+            <a:schemeClr val="lt1"/>
+          </a:fontRef>
+        </p:style>
+        <p:txBody>
+          <a:bodyPr rtlCol="0" anchor="ctr"/>
+          <a:lstStyle/>
+          <a:p>
+            <a:pPr algn="ctr"/>
+            <a:endParaRPr lang="de-DE"/>
+          </a:p>
+        </p:txBody>
+      </p:sp>
+      <p:sp>
+        <p:nvSpPr>
+          <p:cNvPr id="93" name="Rechteck 92">
+            <a:extLst>
+              <a:ext uri="{FF2B5EF4-FFF2-40B4-BE49-F238E27FC236}">
+                <a16:creationId xmlns:a16="http://schemas.microsoft.com/office/drawing/2014/main" id="{3A189544-B87B-027C-DAE2-AB4C1925FB32}"/>
+              </a:ext>
+            </a:extLst>
+          </p:cNvPr>
+          <p:cNvSpPr/>
+          <p:nvPr/>
+        </p:nvSpPr>
+        <p:spPr>
+          <a:xfrm rot="16200000">
+            <a:off x="6284353" y="2894536"/>
+            <a:ext cx="1392590" cy="1126632"/>
+          </a:xfrm>
+          <a:prstGeom prst="rect">
+            <a:avLst/>
+          </a:prstGeom>
+          <a:noFill/>
+          <a:ln w="57150">
+            <a:solidFill>
+              <a:schemeClr val="tx1"/>
+            </a:solidFill>
+          </a:ln>
+        </p:spPr>
+        <p:style>
+          <a:lnRef idx="2">
+            <a:schemeClr val="accent1">
+              <a:shade val="15000"/>
+            </a:schemeClr>
+          </a:lnRef>
+          <a:fillRef idx="1">
+            <a:schemeClr val="accent1"/>
+          </a:fillRef>
+          <a:effectRef idx="0">
+            <a:schemeClr val="accent1"/>
+          </a:effectRef>
+          <a:fontRef idx="minor">
+            <a:schemeClr val="lt1"/>
+          </a:fontRef>
+        </p:style>
+        <p:txBody>
+          <a:bodyPr rtlCol="0" anchor="ctr"/>
+          <a:lstStyle/>
+          <a:p>
+            <a:pPr algn="ctr"/>
+            <a:endParaRPr lang="de-DE"/>
+          </a:p>
+        </p:txBody>
+      </p:sp>
+    </p:spTree>
+    <p:extLst>
+      <p:ext uri="{BB962C8B-B14F-4D97-AF65-F5344CB8AC3E}">
+        <p14:creationId xmlns:p14="http://schemas.microsoft.com/office/powerpoint/2010/main" val="3793324584"/>
+      </p:ext>
+    </p:extLst>
+  </p:cSld>
+  <p:clrMapOvr>
+    <a:masterClrMapping/>
+  </p:clrMapOvr>
+</p:sld>
+</file>
+
 <file path=ppt/slides/slide2.xml><?xml version="1.0" encoding="utf-8"?>
 <p:sld xmlns:a="http://schemas.openxmlformats.org/drawingml/2006/main" xmlns:r="http://schemas.openxmlformats.org/officeDocument/2006/relationships" xmlns:p="http://schemas.openxmlformats.org/presentationml/2006/main">
   <p:cSld>
@@ -52262,15 +54634,6 @@
 </file>
 
 <file path=customXml/item1.xml><?xml version="1.0" encoding="utf-8"?>
-<?mso-contentType ?>
-<FormTemplates xmlns="http://schemas.microsoft.com/sharepoint/v3/contenttype/forms">
-  <Display>DocumentLibraryForm</Display>
-  <Edit>DocumentLibraryForm</Edit>
-  <New>DocumentLibraryForm</New>
-</FormTemplates>
-</file>
-
-<file path=customXml/item2.xml><?xml version="1.0" encoding="utf-8"?>
 <ct:contentTypeSchema xmlns:ct="http://schemas.microsoft.com/office/2006/metadata/contentType" xmlns:ma="http://schemas.microsoft.com/office/2006/metadata/properties/metaAttributes" ct:_="" ma:_="" ma:contentTypeName="Dokument" ma:contentTypeID="0x010100BC5A43B739B3F8438D3442D7065E2F03" ma:contentTypeVersion="8" ma:contentTypeDescription="Ein neues Dokument erstellen." ma:contentTypeScope="" ma:versionID="8ebb2eb0dcccb9c926e45f2ac2a7f64a">
   <xsd:schema xmlns:xsd="http://www.w3.org/2001/XMLSchema" xmlns:xs="http://www.w3.org/2001/XMLSchema" xmlns:p="http://schemas.microsoft.com/office/2006/metadata/properties" xmlns:ns2="814c5c6d-65e8-4717-9aee-c06d9d584814" targetNamespace="http://schemas.microsoft.com/office/2006/metadata/properties" ma:root="true" ma:fieldsID="e566a8717d9f292f1efde37085575ef2" ns2:_="">
     <xsd:import namespace="814c5c6d-65e8-4717-9aee-c06d9d584814"/>
@@ -52442,6 +54805,15 @@
 </ct:contentTypeSchema>
 </file>
 
+<file path=customXml/item2.xml><?xml version="1.0" encoding="utf-8"?>
+<?mso-contentType ?>
+<FormTemplates xmlns="http://schemas.microsoft.com/sharepoint/v3/contenttype/forms">
+  <Display>DocumentLibraryForm</Display>
+  <Edit>DocumentLibraryForm</Edit>
+  <New>DocumentLibraryForm</New>
+</FormTemplates>
+</file>
+
 <file path=customXml/item3.xml><?xml version="1.0" encoding="utf-8"?>
 <p:properties xmlns:p="http://schemas.microsoft.com/office/2006/metadata/properties" xmlns:xsi="http://www.w3.org/2001/XMLSchema-instance" xmlns:pc="http://schemas.microsoft.com/office/infopath/2007/PartnerControls">
   <documentManagement/>
@@ -52449,14 +54821,6 @@
 </file>
 
 <file path=customXml/itemProps1.xml><?xml version="1.0" encoding="utf-8"?>
-<ds:datastoreItem xmlns:ds="http://schemas.openxmlformats.org/officeDocument/2006/customXml" ds:itemID="{4DF6DB84-0773-4571-961D-F1D872F4F170}">
-  <ds:schemaRefs>
-    <ds:schemaRef ds:uri="http://schemas.microsoft.com/sharepoint/v3/contenttype/forms"/>
-  </ds:schemaRefs>
-</ds:datastoreItem>
-</file>
-
-<file path=customXml/itemProps2.xml><?xml version="1.0" encoding="utf-8"?>
 <ds:datastoreItem xmlns:ds="http://schemas.openxmlformats.org/officeDocument/2006/customXml" ds:itemID="{3AF020B6-5615-4388-B89B-B3204D3C239E}">
   <ds:schemaRefs>
     <ds:schemaRef ds:uri="814c5c6d-65e8-4717-9aee-c06d9d584814"/>
@@ -52474,6 +54838,14 @@
 </ds:datastoreItem>
 </file>
 
+<file path=customXml/itemProps2.xml><?xml version="1.0" encoding="utf-8"?>
+<ds:datastoreItem xmlns:ds="http://schemas.openxmlformats.org/officeDocument/2006/customXml" ds:itemID="{4DF6DB84-0773-4571-961D-F1D872F4F170}">
+  <ds:schemaRefs>
+    <ds:schemaRef ds:uri="http://schemas.microsoft.com/sharepoint/v3/contenttype/forms"/>
+  </ds:schemaRefs>
+</ds:datastoreItem>
+</file>
+
 <file path=customXml/itemProps3.xml><?xml version="1.0" encoding="utf-8"?>
 <ds:datastoreItem xmlns:ds="http://schemas.openxmlformats.org/officeDocument/2006/customXml" ds:itemID="{1EFBCB5E-DECB-4440-972A-0F21260E2935}">
   <ds:schemaRefs>

</xml_diff>